<commit_message>
Actualiza lamina 3: evidencia de verificacion ahora incluye dato real
El recuadro "DONDE FALLA" decia "calibrado solo con datos ficticios,
todavia no se probo contra un cierre real de SAP" -- eso ya no es
cierto despues de la validacion de hoy (ver prd-v2.md, punto 14).

Se actualiza el texto de la lamina y las notas del orador para reflejar
que ya se probo contra 1 cuenta real (234101) y el saldo del auxiliar
cuadro al centavo con el F.01, sin perder la honestidad del guardrail:
sigue faltando ampliar la muestra y recalibrar umbrales con datos reales.
El numero grande (100%, 12/12) no cambia -- ese sigue siendo sobre el
dataset ficticio de test_deteccion.py, es una medicion distinta.
</commit_message>
<xml_diff>
--- a/presentacion-analisis-cuentas.pptx
+++ b/presentacion-analisis-cuentas.pptx
@@ -647,7 +647,7 @@
           <a:lstStyle/>
           <a:p>
             <a:r>
-              <a:t>El informe de confiabilidad: numero grande (100%, 12/12), explicacion chica (como se midio), donde falla (solo datos ficticios) y que guardrail se puso (re-test + recalibracion antes de produccion). Nada de promesas, solo lo medido. ~40 seg.</a:t>
+              <a:t>El informe de confiabilidad: numero grande (100%, 12/12, contra datos ficticios), explicacion chica (como se midio), donde falla (ya se probo contra 1 cuenta real de SAP y cuadro al centavo, pero falta ampliar la muestra) y que guardrail se puso (re-test + recalibracion antes de produccion). Nada de promesas, solo lo medido. ~40 seg.</a:t>
             </a:r>
           </a:p>
         </p:txBody>
@@ -5107,7 +5107,7 @@
                 </a:solidFill>
                 <a:latin typeface="Calibri"/>
               </a:rPr>
-              <a:t>Calibrado solo con datos ficticios. Todavia no se probo contra un cierre real de SAP.</a:t>
+              <a:t>Probado con 1 cuenta real (SAP): cuadro al centavo con el F.01. Falta ampliar la muestra y recalibrar umbrales.</a:t>
             </a:r>
           </a:p>
         </p:txBody>

</xml_diff>